<commit_message>
minor updates to day lectures
</commit_message>
<xml_diff>
--- a/assets/lectures/cbw/2026/full/RNASeq_Module0_Introductions.pptx
+++ b/assets/lectures/cbw/2026/full/RNASeq_Module0_Introductions.pptx
@@ -249,8 +249,11 @@
     </a:lvl9pPr>
   </p:defaultTextStyle>
   <p:extLst>
+    <p:ext uri="{EFAFB233-063F-42B5-8137-9DF3F51BA10A}">
+      <p15:sldGuideLst xmlns:p15="http://schemas.microsoft.com/office/powerpoint/2012/main"/>
+    </p:ext>
     <p:ext uri="GoogleSlidesCustomDataVersion2">
-      <go:slidesCustomData xmlns:go="http://customooxmlschemas.google.com/" xmlns:ahyp="http://schemas.microsoft.com/office/drawing/2018/hyperlinkcolor" xmlns:p15="http://schemas.microsoft.com/office/powerpoint/2012/main" xmlns:p14="http://schemas.microsoft.com/office/powerpoint/2010/main" xmlns:com="http://schemas.openxmlformats.org/drawingml/2006/compatibility" xmlns:pvml="urn:schemas-microsoft-com:office:powerpoint" xmlns:v="urn:schemas-microsoft-com:vml" xmlns:o="urn:schemas-microsoft-com:office:office" xmlns:dgm="http://schemas.openxmlformats.org/drawingml/2006/diagram" xmlns:c="http://schemas.openxmlformats.org/drawingml/2006/chart" xmlns:mv="urn:schemas-microsoft-com:mac:vml" xmlns:mc="http://schemas.openxmlformats.org/markup-compatibility/2006" xmlns="" r:id="rId21" roundtripDataSignature="AMtx7mhVbweRC3svyl4ieGmmriuc70gDvQ=="/>
+      <go:slidesCustomData xmlns="" xmlns:mc="http://schemas.openxmlformats.org/markup-compatibility/2006" xmlns:mv="urn:schemas-microsoft-com:mac:vml" xmlns:c="http://schemas.openxmlformats.org/drawingml/2006/chart" xmlns:dgm="http://schemas.openxmlformats.org/drawingml/2006/diagram" xmlns:o="urn:schemas-microsoft-com:office:office" xmlns:v="urn:schemas-microsoft-com:vml" xmlns:pvml="urn:schemas-microsoft-com:office:powerpoint" xmlns:com="http://schemas.openxmlformats.org/drawingml/2006/compatibility" xmlns:p14="http://schemas.microsoft.com/office/powerpoint/2010/main" xmlns:p15="http://schemas.microsoft.com/office/powerpoint/2012/main" xmlns:ahyp="http://schemas.microsoft.com/office/drawing/2018/hyperlinkcolor" xmlns:go="http://customooxmlschemas.google.com/" r:id="rId21" roundtripDataSignature="AMtx7mhVbweRC3svyl4ieGmmriuc70gDvQ=="/>
     </p:ext>
   </p:extLst>
 </p:presentation>
@@ -11047,7 +11050,9 @@
           </a:xfrm>
         </p:spPr>
         <p:txBody>
-          <a:bodyPr/>
+          <a:bodyPr>
+            <a:normAutofit lnSpcReduction="10000"/>
+          </a:bodyPr>
           <a:lstStyle/>
           <a:p>
             <a:pPr marL="0" indent="0">
@@ -11096,6 +11101,17 @@
                 <a:cs typeface="Helvetica Neue" panose="02000503000000020004" pitchFamily="2" charset="0"/>
               </a:rPr>
               <a:t>/command line?</a:t>
+            </a:r>
+          </a:p>
+          <a:p>
+            <a:pPr lvl="1"/>
+            <a:r>
+              <a:rPr lang="en-US" sz="2000" dirty="0">
+                <a:latin typeface="Helvetica Neue" panose="02000503000000020004" pitchFamily="2" charset="0"/>
+                <a:ea typeface="Helvetica Neue" panose="02000503000000020004" pitchFamily="2" charset="0"/>
+                <a:cs typeface="Helvetica Neue" panose="02000503000000020004" pitchFamily="2" charset="0"/>
+              </a:rPr>
+              <a:t>Beginner?</a:t>
             </a:r>
           </a:p>
           <a:p>
@@ -11810,6 +11826,55 @@
                                           <p:spTgt spid="3">
                                             <p:txEl>
                                               <p:pRg st="11" end="11"/>
+                                            </p:txEl>
+                                          </p:spTgt>
+                                        </p:tgtEl>
+                                        <p:attrNameLst>
+                                          <p:attrName>style.visibility</p:attrName>
+                                        </p:attrNameLst>
+                                      </p:cBhvr>
+                                      <p:to>
+                                        <p:strVal val="visible"/>
+                                      </p:to>
+                                    </p:set>
+                                  </p:childTnLst>
+                                </p:cTn>
+                              </p:par>
+                            </p:childTnLst>
+                          </p:cTn>
+                        </p:par>
+                      </p:childTnLst>
+                    </p:cTn>
+                  </p:par>
+                  <p:par>
+                    <p:cTn id="49" fill="hold">
+                      <p:stCondLst>
+                        <p:cond delay="indefinite"/>
+                      </p:stCondLst>
+                      <p:childTnLst>
+                        <p:par>
+                          <p:cTn id="50" fill="hold">
+                            <p:stCondLst>
+                              <p:cond delay="0"/>
+                            </p:stCondLst>
+                            <p:childTnLst>
+                              <p:par>
+                                <p:cTn id="51" presetID="1" presetClass="entr" presetSubtype="0" fill="hold" nodeType="clickEffect">
+                                  <p:stCondLst>
+                                    <p:cond delay="0"/>
+                                  </p:stCondLst>
+                                  <p:childTnLst>
+                                    <p:set>
+                                      <p:cBhvr>
+                                        <p:cTn id="52" dur="1" fill="hold">
+                                          <p:stCondLst>
+                                            <p:cond delay="0"/>
+                                          </p:stCondLst>
+                                        </p:cTn>
+                                        <p:tgtEl>
+                                          <p:spTgt spid="3">
+                                            <p:txEl>
+                                              <p:pRg st="12" end="12"/>
                                             </p:txEl>
                                           </p:spTgt>
                                         </p:tgtEl>

</xml_diff>